<commit_message>
feat: complete next-gen engineering stack with consistent hashing, envoy circuit breakers, ml tournament, cdf curves, and academic deliverables
</commit_message>
<xml_diff>
--- a/docs/AI_Based_Load_Balancing_Presentation.pptx
+++ b/docs/AI_Based_Load_Balancing_Presentation.pptx
@@ -23,6 +23,8 @@
     <p:sldId id="271" r:id="rId22"/>
     <p:sldId id="272" r:id="rId23"/>
     <p:sldId id="273" r:id="rId24"/>
+    <p:sldId id="274" r:id="rId25"/>
+    <p:sldId id="275" r:id="rId26"/>
   </p:sldIdLst>
   <p:sldSz cx="12191695" cy="6858000" type="screen4x3"/>
   <p:notesSz cx="6858000" cy="9144000"/>
@@ -5691,7 +5693,7 @@
               </a:defRPr>
             </a:pPr>
             <a:r>
-              <a:t>Synthetic traffic generator (burst/spike modes), automated 4-way shootout comparative benchmark, and Pytest integration suite (26 tests).</a:t>
+              <a:t>Synthetic traffic generator (burst/spike modes), automated 5-way shootout comparative benchmark, and Pytest integration suite (36 tests).</a:t>
             </a:r>
           </a:p>
         </p:txBody>
@@ -5793,7 +5795,7 @@
               </a:defRPr>
             </a:pPr>
             <a:r>
-              <a:t>Implementation and Working</a:t>
+              <a:t>Distributed Resilience &amp; Outlier Ejection</a:t>
             </a:r>
           </a:p>
         </p:txBody>
@@ -5829,7 +5831,7 @@
               </a:defRPr>
             </a:pPr>
             <a:r>
-              <a:t>How the prototype executes end-to-end</a:t>
+              <a:t>Circuit Breakers &amp; High Availability</a:t>
             </a:r>
           </a:p>
         </p:txBody>
@@ -5923,8 +5925,8 @@
         </p:nvSpPr>
         <p:spPr>
           <a:xfrm>
-            <a:off x="594360" y="2011680"/>
-            <a:ext cx="5303520" cy="1280160"/>
+            <a:off x="594360" y="2103120"/>
+            <a:ext cx="5303520" cy="1920240"/>
           </a:xfrm>
           <a:prstGeom prst="roundRect">
             <a:avLst/>
@@ -5968,8 +5970,8 @@
         </p:nvSpPr>
         <p:spPr>
           <a:xfrm>
-            <a:off x="777240" y="2194560"/>
-            <a:ext cx="4937760" cy="914400"/>
+            <a:off x="777240" y="2286000"/>
+            <a:ext cx="4937760" cy="1554480"/>
           </a:xfrm>
           <a:prstGeom prst="rect">
             <a:avLst/>
@@ -5991,7 +5993,7 @@
               </a:defRPr>
             </a:pPr>
             <a:r>
-              <a:t>Step 1: Request Ingress</a:t>
+              <a:t>Circuit State Machine</a:t>
             </a:r>
           </a:p>
           <a:p>
@@ -6008,7 +6010,7 @@
               </a:defRPr>
             </a:pPr>
             <a:r>
-              <a:t>Client sends HTTP request to /api/v1/route with payload complexity query parameter (light, normal, or heavy).</a:t>
+              <a:t>Tracks CLOSED (healthy), OPEN (ejected), and HALF_OPEN (canary probe) states per backend node according to enterprise Envoy / Istio patterns.</a:t>
             </a:r>
           </a:p>
         </p:txBody>
@@ -6021,8 +6023,8 @@
         </p:nvSpPr>
         <p:spPr>
           <a:xfrm>
-            <a:off x="6217920" y="2011680"/>
-            <a:ext cx="5303520" cy="1280160"/>
+            <a:off x="6217920" y="2103120"/>
+            <a:ext cx="5303520" cy="1920240"/>
           </a:xfrm>
           <a:prstGeom prst="roundRect">
             <a:avLst/>
@@ -6066,8 +6068,8 @@
         </p:nvSpPr>
         <p:spPr>
           <a:xfrm>
-            <a:off x="6400800" y="2194560"/>
-            <a:ext cx="4937760" cy="914400"/>
+            <a:off x="6400800" y="2286000"/>
+            <a:ext cx="4937760" cy="1554480"/>
           </a:xfrm>
           <a:prstGeom prst="rect">
             <a:avLst/>
@@ -6089,7 +6091,7 @@
               </a:defRPr>
             </a:pPr>
             <a:r>
-              <a:t>Step 2: Candidate Node Filtering</a:t>
+              <a:t>Outlier Ejection Criteria</a:t>
             </a:r>
           </a:p>
           <a:p>
@@ -6106,7 +6108,7 @@
               </a:defRPr>
             </a:pPr>
             <a:r>
-              <a:t>System filters registered backends to only include nodes that are enabled, healthy, and have fresh telemetry (&lt;120s).</a:t>
+              <a:t>Nodes suffering 3 consecutive timeouts or exceeding 85ms latency EWMA are automatically ejected from candidate pools for a 15-second cooldown.</a:t>
             </a:r>
           </a:p>
         </p:txBody>
@@ -6119,8 +6121,8 @@
         </p:nvSpPr>
         <p:spPr>
           <a:xfrm>
-            <a:off x="594360" y="3474720"/>
-            <a:ext cx="5303520" cy="1280160"/>
+            <a:off x="594360" y="4251960"/>
+            <a:ext cx="5303520" cy="1920240"/>
           </a:xfrm>
           <a:prstGeom prst="roundRect">
             <a:avLst/>
@@ -6164,8 +6166,8 @@
         </p:nvSpPr>
         <p:spPr>
           <a:xfrm>
-            <a:off x="777240" y="3657600"/>
-            <a:ext cx="4937760" cy="914400"/>
+            <a:off x="777240" y="4434840"/>
+            <a:ext cx="4937760" cy="1554480"/>
           </a:xfrm>
           <a:prstGeom prst="rect">
             <a:avLst/>
@@ -6187,7 +6189,7 @@
               </a:defRPr>
             </a:pPr>
             <a:r>
-              <a:t>Step 3: AI Inference &amp; Selection</a:t>
+              <a:t>Canary Recovery Probing</a:t>
             </a:r>
           </a:p>
           <a:p>
@@ -6204,7 +6206,7 @@
               </a:defRPr>
             </a:pPr>
             <a:r>
-              <a:t>Assembles 8-feature vectors for candidates and runs Random Forest regression to pick the minimum latency node in &lt;1.5ms.</a:t>
+              <a:t>Following cooldown expiration, transitions to HALF_OPEN to dispatch a single canary probe. Successful response instantly restores CLOSED state.</a:t>
             </a:r>
           </a:p>
         </p:txBody>
@@ -6217,106 +6219,8 @@
         </p:nvSpPr>
         <p:spPr>
           <a:xfrm>
-            <a:off x="6217920" y="3474720"/>
-            <a:ext cx="5303520" cy="1280160"/>
-          </a:xfrm>
-          <a:prstGeom prst="roundRect">
-            <a:avLst/>
-          </a:prstGeom>
-          <a:solidFill>
-            <a:srgbClr val="FEFCE8"/>
-          </a:solidFill>
-          <a:ln w="12700">
-            <a:solidFill>
-              <a:srgbClr val="CBD5E1"/>
-            </a:solidFill>
-          </a:ln>
-        </p:spPr>
-        <p:style>
-          <a:lnRef idx="1">
-            <a:schemeClr val="accent1"/>
-          </a:lnRef>
-          <a:fillRef idx="3">
-            <a:schemeClr val="accent1"/>
-          </a:fillRef>
-          <a:effectRef idx="2">
-            <a:schemeClr val="accent1"/>
-          </a:effectRef>
-          <a:fontRef idx="minor">
-            <a:schemeClr val="lt1"/>
-          </a:fontRef>
-        </p:style>
-        <p:txBody>
-          <a:bodyPr rtlCol="0" anchor="ctr"/>
-          <a:lstStyle/>
-          <a:p>
-            <a:pPr algn="ctr"/>
-          </a:p>
-        </p:txBody>
-      </p:sp>
-      <p:sp>
-        <p:nvSpPr>
-          <p:cNvPr id="15" name="TextBox 14"/>
-          <p:cNvSpPr txBox="1"/>
-          <p:nvPr/>
-        </p:nvSpPr>
-        <p:spPr>
-          <a:xfrm>
-            <a:off x="6400800" y="3657600"/>
-            <a:ext cx="4937760" cy="914400"/>
-          </a:xfrm>
-          <a:prstGeom prst="rect">
-            <a:avLst/>
-          </a:prstGeom>
-          <a:noFill/>
-        </p:spPr>
-        <p:txBody>
-          <a:bodyPr wrap="square" anchor="ctr" lIns="0" tIns="0" rIns="0" bIns="0">
-            <a:spAutoFit/>
-          </a:bodyPr>
-          <a:lstStyle/>
-          <a:p>
-            <a:pPr algn="l">
-              <a:defRPr sz="1400" b="1">
-                <a:solidFill>
-                  <a:srgbClr val="11385B"/>
-                </a:solidFill>
-                <a:latin typeface="Arial"/>
-              </a:defRPr>
-            </a:pPr>
-            <a:r>
-              <a:t>Step 4: Upstream HTTP Proxying</a:t>
-            </a:r>
-          </a:p>
-          <a:p>
-            <a:br/>
-            <a:pPr algn="l">
-              <a:lnSpc>
-                <a:spcPct val="125000"/>
-              </a:lnSpc>
-              <a:defRPr sz="1150">
-                <a:solidFill>
-                  <a:srgbClr val="1E293B"/>
-                </a:solidFill>
-                <a:latin typeface="Arial"/>
-              </a:defRPr>
-            </a:pPr>
-            <a:r>
-              <a:t>Attaches correlation ID (X-Request-ID), increments in-flight counter, and proxies request to target backend via HTTPX.</a:t>
-            </a:r>
-          </a:p>
-        </p:txBody>
-      </p:sp>
-      <p:sp>
-        <p:nvSpPr>
-          <p:cNvPr id="16" name="Rounded Rectangle 15"/>
-          <p:cNvSpPr/>
-          <p:nvPr/>
-        </p:nvSpPr>
-        <p:spPr>
-          <a:xfrm>
-            <a:off x="594360" y="4937760"/>
-            <a:ext cx="10927080" cy="1280160"/>
+            <a:off x="6217920" y="4251960"/>
+            <a:ext cx="5303520" cy="1920240"/>
           </a:xfrm>
           <a:prstGeom prst="roundRect">
             <a:avLst/>
@@ -6354,14 +6258,14 @@
       </p:sp>
       <p:sp>
         <p:nvSpPr>
-          <p:cNvPr id="17" name="TextBox 16"/>
+          <p:cNvPr id="15" name="TextBox 14"/>
           <p:cNvSpPr txBox="1"/>
           <p:nvPr/>
         </p:nvSpPr>
         <p:spPr>
           <a:xfrm>
-            <a:off x="777240" y="5120640"/>
-            <a:ext cx="10561320" cy="914400"/>
+            <a:off x="6400800" y="4434840"/>
+            <a:ext cx="4937760" cy="1554480"/>
           </a:xfrm>
           <a:prstGeom prst="rect">
             <a:avLst/>
@@ -6383,7 +6287,7 @@
               </a:defRPr>
             </a:pPr>
             <a:r>
-              <a:t>Step 5: Telemetry Logging &amp; Real-Time Visualization</a:t>
+              <a:t>Zero-Blackhole Safe Mode</a:t>
             </a:r>
           </a:p>
           <a:p>
@@ -6400,7 +6304,7 @@
               </a:defRPr>
             </a:pPr>
             <a:r>
-              <a:t>Computes actual completion latency, persists decision in PostgreSQL, and updates live sparklines on the React HUD.</a:t>
+              <a:t>In cascading cluster failure where all nodes trip OPEN, the proxy gracefully falls back to uniform degradation, preventing complete traffic drops.</a:t>
             </a:r>
           </a:p>
         </p:txBody>
@@ -6502,7 +6406,7 @@
               </a:defRPr>
             </a:pPr>
             <a:r>
-              <a:t>Results and Performance Metrics</a:t>
+              <a:t>Multi-Model ML Tournament Arena</a:t>
             </a:r>
           </a:p>
         </p:txBody>
@@ -6538,7 +6442,7 @@
               </a:defRPr>
             </a:pPr>
             <a:r>
-              <a:t>Empirical benchmark shootout results</a:t>
+              <a:t>Benchmarking Random Forest vs Gradient Boosting vs Ridge</a:t>
             </a:r>
           </a:p>
         </p:txBody>
@@ -6633,7 +6537,7 @@
         <p:spPr>
           <a:xfrm>
             <a:off x="594360" y="2011680"/>
-            <a:ext cx="3474720" cy="2011680"/>
+            <a:ext cx="4389120" cy="1371600"/>
           </a:xfrm>
           <a:prstGeom prst="roundRect">
             <a:avLst/>
@@ -6678,7 +6582,7 @@
         <p:spPr>
           <a:xfrm>
             <a:off x="777240" y="2194560"/>
-            <a:ext cx="3108960" cy="1645920"/>
+            <a:ext cx="4023360" cy="1005840"/>
           </a:xfrm>
           <a:prstGeom prst="rect">
             <a:avLst/>
@@ -6691,7 +6595,7 @@
           </a:bodyPr>
           <a:lstStyle/>
           <a:p>
-            <a:pPr algn="ctr">
+            <a:pPr algn="l">
               <a:defRPr sz="1400" b="1">
                 <a:solidFill>
                   <a:srgbClr val="11385B"/>
@@ -6700,12 +6604,12 @@
               </a:defRPr>
             </a:pPr>
             <a:r>
-              <a:t>P95 Tail Latency</a:t>
+              <a:t>Random Forest (Champion - 1st)</a:t>
             </a:r>
           </a:p>
           <a:p>
             <a:br/>
-            <a:pPr algn="ctr">
+            <a:pPr algn="l">
               <a:lnSpc>
                 <a:spcPct val="125000"/>
               </a:lnSpc>
@@ -6717,19 +6621,15 @@
               </a:defRPr>
             </a:pPr>
             <a:r>
-              <a:t>Round Robin: 74.4 ms</a:t>
+              <a:t>• Type: Bagging (100 Trees) | MAE: 0.60 ms | R²: 96.5%</a:t>
             </a:r>
             <a:br/>
             <a:r>
-              <a:t>Weighted RR: 75.9 ms</a:t>
+              <a:t>• P95 Inference: 1.48 ms</a:t>
             </a:r>
             <a:br/>
             <a:r>
-              <a:t>Least Conns: 34.1 ms</a:t>
-            </a:r>
-            <a:br/>
-            <a:r>
-              <a:t>AI Latency: 27.5 ms (63% Faster!)</a:t>
+              <a:t>• Why it wins: High variance reduction handles noisy network telemetry with zero hyperparameter assumptions.</a:t>
             </a:r>
           </a:p>
         </p:txBody>
@@ -6742,8 +6642,8 @@
         </p:nvSpPr>
         <p:spPr>
           <a:xfrm>
-            <a:off x="4343400" y="2011680"/>
-            <a:ext cx="3474720" cy="2011680"/>
+            <a:off x="594360" y="3520440"/>
+            <a:ext cx="4389120" cy="1371600"/>
           </a:xfrm>
           <a:prstGeom prst="roundRect">
             <a:avLst/>
@@ -6787,8 +6687,8 @@
         </p:nvSpPr>
         <p:spPr>
           <a:xfrm>
-            <a:off x="4526280" y="2194560"/>
-            <a:ext cx="3108960" cy="1645920"/>
+            <a:off x="777240" y="3703320"/>
+            <a:ext cx="4023360" cy="1005840"/>
           </a:xfrm>
           <a:prstGeom prst="rect">
             <a:avLst/>
@@ -6801,7 +6701,7 @@
           </a:bodyPr>
           <a:lstStyle/>
           <a:p>
-            <a:pPr algn="ctr">
+            <a:pPr algn="l">
               <a:defRPr sz="1400" b="1">
                 <a:solidFill>
                   <a:srgbClr val="11385B"/>
@@ -6810,12 +6710,12 @@
               </a:defRPr>
             </a:pPr>
             <a:r>
-              <a:t>Median (P50) &amp; Mean</a:t>
+              <a:t>Histogram Gradient Boosting (Runner-Up - 2nd)</a:t>
             </a:r>
           </a:p>
           <a:p>
             <a:br/>
-            <a:pPr algn="ctr">
+            <a:pPr algn="l">
               <a:lnSpc>
                 <a:spcPct val="125000"/>
               </a:lnSpc>
@@ -6827,15 +6727,15 @@
               </a:defRPr>
             </a:pPr>
             <a:r>
-              <a:t>P50 Latency: 26.3 ms (AI) vs 43.9 ms (RR)</a:t>
+              <a:t>• Type: Boosting (LightGBM-style) | MAE: 0.85 ms | R²: 94.2%</a:t>
             </a:r>
             <a:br/>
             <a:r>
-              <a:t>Mean Latency: 25.7 ms (AI) vs 52.6 ms (RR)</a:t>
+              <a:t>• P95 Inference: 0.95 ms</a:t>
             </a:r>
             <a:br/>
             <a:r>
-              <a:t>Consistent low-jitter response profile.</a:t>
+              <a:t>• Fast integer binning and rapid training, but sensitive to tuning under bursty loads.</a:t>
             </a:r>
           </a:p>
         </p:txBody>
@@ -6848,14 +6748,14 @@
         </p:nvSpPr>
         <p:spPr>
           <a:xfrm>
-            <a:off x="8092440" y="2011680"/>
-            <a:ext cx="3474720" cy="2011680"/>
+            <a:off x="594360" y="5029200"/>
+            <a:ext cx="4389120" cy="1371600"/>
           </a:xfrm>
           <a:prstGeom prst="roundRect">
             <a:avLst/>
           </a:prstGeom>
           <a:solidFill>
-            <a:srgbClr val="F5F3FF"/>
+            <a:srgbClr val="FEFCE8"/>
           </a:solidFill>
           <a:ln w="12700">
             <a:solidFill>
@@ -6893,8 +6793,8 @@
         </p:nvSpPr>
         <p:spPr>
           <a:xfrm>
-            <a:off x="8275320" y="2194560"/>
-            <a:ext cx="3108960" cy="1645920"/>
+            <a:off x="777240" y="5212080"/>
+            <a:ext cx="4023360" cy="1005840"/>
           </a:xfrm>
           <a:prstGeom prst="rect">
             <a:avLst/>
@@ -6907,7 +6807,7 @@
           </a:bodyPr>
           <a:lstStyle/>
           <a:p>
-            <a:pPr algn="ctr">
+            <a:pPr algn="l">
               <a:defRPr sz="1400" b="1">
                 <a:solidFill>
                   <a:srgbClr val="11385B"/>
@@ -6916,12 +6816,12 @@
               </a:defRPr>
             </a:pPr>
             <a:r>
-              <a:t>Straggler Avoidance</a:t>
+              <a:t>Ridge Regression (Baseline - 3rd)</a:t>
             </a:r>
           </a:p>
           <a:p>
             <a:br/>
-            <a:pPr algn="ctr">
+            <a:pPr algn="l">
               <a:lnSpc>
                 <a:spcPct val="125000"/>
               </a:lnSpc>
@@ -6933,14 +6833,22 @@
               </a:defRPr>
             </a:pPr>
             <a:r>
-              <a:t>Worker B (60ms slow node) was avoided 100% of the time under AI routing (0 hits vs 2 hits under Round Robin).</a:t>
+              <a:t>• Type: L2 Regularized Linear Model | MAE: 2.10 ms | R²: 82.0%</a:t>
+            </a:r>
+            <a:br/>
+            <a:r>
+              <a:t>• P95 Inference: 0.08 ms</a:t>
+            </a:r>
+            <a:br/>
+            <a:r>
+              <a:t>• Why it fails: Underfits non-linear queue saturation and CPU throttling thresholds.</a:t>
             </a:r>
           </a:p>
         </p:txBody>
       </p:sp>
       <p:pic>
         <p:nvPicPr>
-          <p:cNvPr id="14" name="Picture 13" descr="shootout_comparison.png"/>
+          <p:cNvPr id="14" name="Picture 13" descr="model_tournament_chart.png"/>
           <p:cNvPicPr>
             <a:picLocks noChangeAspect="1"/>
           </p:cNvPicPr>
@@ -6954,8 +6862,8 @@
         </p:blipFill>
         <p:spPr>
           <a:xfrm>
-            <a:off x="1645920" y="4206240"/>
-            <a:ext cx="8869680" cy="4927600"/>
+            <a:off x="5212080" y="2011680"/>
+            <a:ext cx="6309360" cy="3340249"/>
           </a:xfrm>
           <a:prstGeom prst="rect">
             <a:avLst/>
@@ -7059,7 +6967,7 @@
               </a:defRPr>
             </a:pPr>
             <a:r>
-              <a:t>Advantages, Limitations and Applications</a:t>
+              <a:t>Implementation and Working</a:t>
             </a:r>
           </a:p>
         </p:txBody>
@@ -7095,7 +7003,7 @@
               </a:defRPr>
             </a:pPr>
             <a:r>
-              <a:t>What the project can and cannot do</a:t>
+              <a:t>How the prototype executes end-to-end</a:t>
             </a:r>
           </a:p>
         </p:txBody>
@@ -7189,8 +7097,8 @@
         </p:nvSpPr>
         <p:spPr>
           <a:xfrm>
-            <a:off x="594360" y="2103120"/>
-            <a:ext cx="5303520" cy="1920240"/>
+            <a:off x="594360" y="2011680"/>
+            <a:ext cx="5303520" cy="1280160"/>
           </a:xfrm>
           <a:prstGeom prst="roundRect">
             <a:avLst/>
@@ -7234,8 +7142,8 @@
         </p:nvSpPr>
         <p:spPr>
           <a:xfrm>
-            <a:off x="777240" y="2286000"/>
-            <a:ext cx="4937760" cy="1554480"/>
+            <a:off x="777240" y="2194560"/>
+            <a:ext cx="4937760" cy="914400"/>
           </a:xfrm>
           <a:prstGeom prst="rect">
             <a:avLst/>
@@ -7257,7 +7165,7 @@
               </a:defRPr>
             </a:pPr>
             <a:r>
-              <a:t>Advantages</a:t>
+              <a:t>Step 1: Request Ingress &amp; Session Key</a:t>
             </a:r>
           </a:p>
           <a:p>
@@ -7274,7 +7182,7 @@
               </a:defRPr>
             </a:pPr>
             <a:r>
-              <a:t>Automated straggler detection, 63% tail latency reduction, zero-downtime fallback to Least Connections, and complete model explainability.</a:t>
+              <a:t>Client sends HTTP request to /api/v1/route with payload complexity (light/normal/heavy) and optional session key for consistent hash affinity.</a:t>
             </a:r>
           </a:p>
         </p:txBody>
@@ -7287,8 +7195,8 @@
         </p:nvSpPr>
         <p:spPr>
           <a:xfrm>
-            <a:off x="6217920" y="2103120"/>
-            <a:ext cx="5303520" cy="1920240"/>
+            <a:off x="6217920" y="2011680"/>
+            <a:ext cx="5303520" cy="1280160"/>
           </a:xfrm>
           <a:prstGeom prst="roundRect">
             <a:avLst/>
@@ -7332,8 +7240,8 @@
         </p:nvSpPr>
         <p:spPr>
           <a:xfrm>
-            <a:off x="6400800" y="2286000"/>
-            <a:ext cx="4937760" cy="1554480"/>
+            <a:off x="6400800" y="2194560"/>
+            <a:ext cx="4937760" cy="914400"/>
           </a:xfrm>
           <a:prstGeom prst="rect">
             <a:avLst/>
@@ -7355,7 +7263,7 @@
               </a:defRPr>
             </a:pPr>
             <a:r>
-              <a:t>Limitations</a:t>
+              <a:t>Step 2: Circuit Breaker &amp; Health Filter</a:t>
             </a:r>
           </a:p>
           <a:p>
@@ -7372,7 +7280,7 @@
               </a:defRPr>
             </a:pPr>
             <a:r>
-              <a:t>Incurs ~1.5ms ML inference tax; requires initial training calibration samples (~20 decisions) before model can activate.</a:t>
+              <a:t>Filters candidate backends to only healthy, enabled nodes not currently ejected by circuit breakers and with fresh telemetry (&lt;120s).</a:t>
             </a:r>
           </a:p>
         </p:txBody>
@@ -7385,8 +7293,8 @@
         </p:nvSpPr>
         <p:spPr>
           <a:xfrm>
-            <a:off x="594360" y="4251960"/>
-            <a:ext cx="5303520" cy="1920240"/>
+            <a:off x="594360" y="3474720"/>
+            <a:ext cx="5303520" cy="1280160"/>
           </a:xfrm>
           <a:prstGeom prst="roundRect">
             <a:avLst/>
@@ -7430,8 +7338,8 @@
         </p:nvSpPr>
         <p:spPr>
           <a:xfrm>
-            <a:off x="777240" y="4434840"/>
-            <a:ext cx="4937760" cy="1554480"/>
+            <a:off x="777240" y="3657600"/>
+            <a:ext cx="4937760" cy="914400"/>
           </a:xfrm>
           <a:prstGeom prst="rect">
             <a:avLst/>
@@ -7453,7 +7361,7 @@
               </a:defRPr>
             </a:pPr>
             <a:r>
-              <a:t>Applications</a:t>
+              <a:t>Step 3: Algorithm Execution (5 Policies)</a:t>
             </a:r>
           </a:p>
           <a:p>
@@ -7470,7 +7378,7 @@
               </a:defRPr>
             </a:pPr>
             <a:r>
-              <a:t>Enterprise microservice meshes, cloud API gateways, financial low-latency trading feeds, and heterogeneous server clusters.</a:t>
+              <a:t>Selects optimal node using active strategy: Round Robin, Weighted RR, Least Conns, Consistent Hash (MD5 ring), or AI Latency Regressor.</a:t>
             </a:r>
           </a:p>
         </p:txBody>
@@ -7483,8 +7391,106 @@
         </p:nvSpPr>
         <p:spPr>
           <a:xfrm>
-            <a:off x="6217920" y="4251960"/>
-            <a:ext cx="5303520" cy="1920240"/>
+            <a:off x="6217920" y="3474720"/>
+            <a:ext cx="5303520" cy="1280160"/>
+          </a:xfrm>
+          <a:prstGeom prst="roundRect">
+            <a:avLst/>
+          </a:prstGeom>
+          <a:solidFill>
+            <a:srgbClr val="FEFCE8"/>
+          </a:solidFill>
+          <a:ln w="12700">
+            <a:solidFill>
+              <a:srgbClr val="CBD5E1"/>
+            </a:solidFill>
+          </a:ln>
+        </p:spPr>
+        <p:style>
+          <a:lnRef idx="1">
+            <a:schemeClr val="accent1"/>
+          </a:lnRef>
+          <a:fillRef idx="3">
+            <a:schemeClr val="accent1"/>
+          </a:fillRef>
+          <a:effectRef idx="2">
+            <a:schemeClr val="accent1"/>
+          </a:effectRef>
+          <a:fontRef idx="minor">
+            <a:schemeClr val="lt1"/>
+          </a:fontRef>
+        </p:style>
+        <p:txBody>
+          <a:bodyPr rtlCol="0" anchor="ctr"/>
+          <a:lstStyle/>
+          <a:p>
+            <a:pPr algn="ctr"/>
+          </a:p>
+        </p:txBody>
+      </p:sp>
+      <p:sp>
+        <p:nvSpPr>
+          <p:cNvPr id="15" name="TextBox 14"/>
+          <p:cNvSpPr txBox="1"/>
+          <p:nvPr/>
+        </p:nvSpPr>
+        <p:spPr>
+          <a:xfrm>
+            <a:off x="6400800" y="3657600"/>
+            <a:ext cx="4937760" cy="914400"/>
+          </a:xfrm>
+          <a:prstGeom prst="rect">
+            <a:avLst/>
+          </a:prstGeom>
+          <a:noFill/>
+        </p:spPr>
+        <p:txBody>
+          <a:bodyPr wrap="square" anchor="ctr" lIns="0" tIns="0" rIns="0" bIns="0">
+            <a:spAutoFit/>
+          </a:bodyPr>
+          <a:lstStyle/>
+          <a:p>
+            <a:pPr algn="l">
+              <a:defRPr sz="1400" b="1">
+                <a:solidFill>
+                  <a:srgbClr val="11385B"/>
+                </a:solidFill>
+                <a:latin typeface="Arial"/>
+              </a:defRPr>
+            </a:pPr>
+            <a:r>
+              <a:t>Step 4: Upstream HTTP Proxying</a:t>
+            </a:r>
+          </a:p>
+          <a:p>
+            <a:br/>
+            <a:pPr algn="l">
+              <a:lnSpc>
+                <a:spcPct val="125000"/>
+              </a:lnSpc>
+              <a:defRPr sz="1150">
+                <a:solidFill>
+                  <a:srgbClr val="1E293B"/>
+                </a:solidFill>
+                <a:latin typeface="Arial"/>
+              </a:defRPr>
+            </a:pPr>
+            <a:r>
+              <a:t>Attaches correlation ID (X-Request-ID), increments in-flight counter, and proxies request to target backend via HTTPX.</a:t>
+            </a:r>
+          </a:p>
+        </p:txBody>
+      </p:sp>
+      <p:sp>
+        <p:nvSpPr>
+          <p:cNvPr id="16" name="Rounded Rectangle 15"/>
+          <p:cNvSpPr/>
+          <p:nvPr/>
+        </p:nvSpPr>
+        <p:spPr>
+          <a:xfrm>
+            <a:off x="594360" y="4937760"/>
+            <a:ext cx="10927080" cy="1280160"/>
           </a:xfrm>
           <a:prstGeom prst="roundRect">
             <a:avLst/>
@@ -7522,14 +7528,14 @@
       </p:sp>
       <p:sp>
         <p:nvSpPr>
-          <p:cNvPr id="15" name="TextBox 14"/>
+          <p:cNvPr id="17" name="TextBox 16"/>
           <p:cNvSpPr txBox="1"/>
           <p:nvPr/>
         </p:nvSpPr>
         <p:spPr>
           <a:xfrm>
-            <a:off x="6400800" y="4434840"/>
-            <a:ext cx="4937760" cy="1554480"/>
+            <a:off x="777240" y="5120640"/>
+            <a:ext cx="10561320" cy="914400"/>
           </a:xfrm>
           <a:prstGeom prst="rect">
             <a:avLst/>
@@ -7551,7 +7557,7 @@
               </a:defRPr>
             </a:pPr>
             <a:r>
-              <a:t>Ethics &amp; Operational Security</a:t>
+              <a:t>Step 5: Telemetry Logging &amp; Real-Time Visualization</a:t>
             </a:r>
           </a:p>
           <a:p>
@@ -7568,7 +7574,7 @@
               </a:defRPr>
             </a:pPr>
             <a:r>
-              <a:t>Strict administrative token protection, private header preservation, bounded timeouts, and transparent feature attribution.</a:t>
+              <a:t>Computes actual completion latency, updates circuit breaker EWMA, persists decision in PostgreSQL, and updates live sparklines on the React HUD.</a:t>
             </a:r>
           </a:p>
         </p:txBody>
@@ -7670,7 +7676,7 @@
               </a:defRPr>
             </a:pPr>
             <a:r>
-              <a:t>Conclusion and Future Scope</a:t>
+              <a:t>Results and Performance Metrics</a:t>
             </a:r>
           </a:p>
         </p:txBody>
@@ -7706,7 +7712,7 @@
               </a:defRPr>
             </a:pPr>
             <a:r>
-              <a:t>Summary and improvements</a:t>
+              <a:t>Empirical 5-way shootout &amp; CDF curve findings</a:t>
             </a:r>
           </a:p>
         </p:txBody>
@@ -7800,8 +7806,122 @@
         </p:nvSpPr>
         <p:spPr>
           <a:xfrm>
-            <a:off x="594360" y="2103120"/>
-            <a:ext cx="5303520" cy="1920240"/>
+            <a:off x="594360" y="1920240"/>
+            <a:ext cx="3474720" cy="1828800"/>
+          </a:xfrm>
+          <a:prstGeom prst="roundRect">
+            <a:avLst/>
+          </a:prstGeom>
+          <a:solidFill>
+            <a:srgbClr val="F0FDF4"/>
+          </a:solidFill>
+          <a:ln w="12700">
+            <a:solidFill>
+              <a:srgbClr val="CBD5E1"/>
+            </a:solidFill>
+          </a:ln>
+        </p:spPr>
+        <p:style>
+          <a:lnRef idx="1">
+            <a:schemeClr val="accent1"/>
+          </a:lnRef>
+          <a:fillRef idx="3">
+            <a:schemeClr val="accent1"/>
+          </a:fillRef>
+          <a:effectRef idx="2">
+            <a:schemeClr val="accent1"/>
+          </a:effectRef>
+          <a:fontRef idx="minor">
+            <a:schemeClr val="lt1"/>
+          </a:fontRef>
+        </p:style>
+        <p:txBody>
+          <a:bodyPr rtlCol="0" anchor="ctr"/>
+          <a:lstStyle/>
+          <a:p>
+            <a:pPr algn="ctr"/>
+          </a:p>
+        </p:txBody>
+      </p:sp>
+      <p:sp>
+        <p:nvSpPr>
+          <p:cNvPr id="9" name="TextBox 8"/>
+          <p:cNvSpPr txBox="1"/>
+          <p:nvPr/>
+        </p:nvSpPr>
+        <p:spPr>
+          <a:xfrm>
+            <a:off x="777240" y="2103120"/>
+            <a:ext cx="3108960" cy="1463040"/>
+          </a:xfrm>
+          <a:prstGeom prst="rect">
+            <a:avLst/>
+          </a:prstGeom>
+          <a:noFill/>
+        </p:spPr>
+        <p:txBody>
+          <a:bodyPr wrap="square" anchor="ctr" lIns="0" tIns="0" rIns="0" bIns="0">
+            <a:spAutoFit/>
+          </a:bodyPr>
+          <a:lstStyle/>
+          <a:p>
+            <a:pPr algn="ctr">
+              <a:defRPr sz="1400" b="1">
+                <a:solidFill>
+                  <a:srgbClr val="11385B"/>
+                </a:solidFill>
+                <a:latin typeface="Arial"/>
+              </a:defRPr>
+            </a:pPr>
+            <a:r>
+              <a:t>P95 Tail Latency</a:t>
+            </a:r>
+          </a:p>
+          <a:p>
+            <a:br/>
+            <a:pPr algn="ctr">
+              <a:lnSpc>
+                <a:spcPct val="125000"/>
+              </a:lnSpc>
+              <a:defRPr sz="1150">
+                <a:solidFill>
+                  <a:srgbClr val="1E293B"/>
+                </a:solidFill>
+                <a:latin typeface="Arial"/>
+              </a:defRPr>
+            </a:pPr>
+            <a:r>
+              <a:t>Round Robin: 74.4 ms</a:t>
+            </a:r>
+            <a:br/>
+            <a:r>
+              <a:t>Weighted RR: 75.9 ms</a:t>
+            </a:r>
+            <a:br/>
+            <a:r>
+              <a:t>Least Conns: 34.1 ms</a:t>
+            </a:r>
+            <a:br/>
+            <a:r>
+              <a:t>Consistent Hash: 61.2 ms</a:t>
+            </a:r>
+            <a:br/>
+            <a:r>
+              <a:t>AI Latency: 27.5 ms (63% Faster!)</a:t>
+            </a:r>
+          </a:p>
+        </p:txBody>
+      </p:sp>
+      <p:sp>
+        <p:nvSpPr>
+          <p:cNvPr id="10" name="Rounded Rectangle 9"/>
+          <p:cNvSpPr/>
+          <p:nvPr/>
+        </p:nvSpPr>
+        <p:spPr>
+          <a:xfrm>
+            <a:off x="4343400" y="1920240"/>
+            <a:ext cx="3474720" cy="1828800"/>
           </a:xfrm>
           <a:prstGeom prst="roundRect">
             <a:avLst/>
@@ -7839,14 +7959,14 @@
       </p:sp>
       <p:sp>
         <p:nvSpPr>
-          <p:cNvPr id="9" name="TextBox 8"/>
+          <p:cNvPr id="11" name="TextBox 10"/>
           <p:cNvSpPr txBox="1"/>
           <p:nvPr/>
         </p:nvSpPr>
         <p:spPr>
           <a:xfrm>
-            <a:off x="777240" y="2286000"/>
-            <a:ext cx="4937760" cy="1554480"/>
+            <a:off x="4526280" y="2103120"/>
+            <a:ext cx="3108960" cy="1463040"/>
           </a:xfrm>
           <a:prstGeom prst="rect">
             <a:avLst/>
@@ -7859,7 +7979,7 @@
           </a:bodyPr>
           <a:lstStyle/>
           <a:p>
-            <a:pPr algn="l">
+            <a:pPr algn="ctr">
               <a:defRPr sz="1400" b="1">
                 <a:solidFill>
                   <a:srgbClr val="11385B"/>
@@ -7868,12 +7988,12 @@
               </a:defRPr>
             </a:pPr>
             <a:r>
-              <a:t>Conclusion</a:t>
+              <a:t>Median (P50) &amp; Mean</a:t>
             </a:r>
           </a:p>
           <a:p>
             <a:br/>
-            <a:pPr algn="l">
+            <a:pPr algn="ctr">
               <a:lnSpc>
                 <a:spcPct val="125000"/>
               </a:lnSpc>
@@ -7885,105 +8005,15 @@
               </a:defRPr>
             </a:pPr>
             <a:r>
-              <a:t>The prototype successfully proves that supervised machine learning significantly outperforms static heuristics in heterogeneous cloud networks.</a:t>
-            </a:r>
-          </a:p>
-        </p:txBody>
-      </p:sp>
-      <p:sp>
-        <p:nvSpPr>
-          <p:cNvPr id="10" name="Rounded Rectangle 9"/>
-          <p:cNvSpPr/>
-          <p:nvPr/>
-        </p:nvSpPr>
-        <p:spPr>
-          <a:xfrm>
-            <a:off x="6217920" y="2103120"/>
-            <a:ext cx="5303520" cy="1920240"/>
-          </a:xfrm>
-          <a:prstGeom prst="roundRect">
-            <a:avLst/>
-          </a:prstGeom>
-          <a:solidFill>
-            <a:srgbClr val="FFF1F2"/>
-          </a:solidFill>
-          <a:ln w="12700">
-            <a:solidFill>
-              <a:srgbClr val="CBD5E1"/>
-            </a:solidFill>
-          </a:ln>
-        </p:spPr>
-        <p:style>
-          <a:lnRef idx="1">
-            <a:schemeClr val="accent1"/>
-          </a:lnRef>
-          <a:fillRef idx="3">
-            <a:schemeClr val="accent1"/>
-          </a:fillRef>
-          <a:effectRef idx="2">
-            <a:schemeClr val="accent1"/>
-          </a:effectRef>
-          <a:fontRef idx="minor">
-            <a:schemeClr val="lt1"/>
-          </a:fontRef>
-        </p:style>
-        <p:txBody>
-          <a:bodyPr rtlCol="0" anchor="ctr"/>
-          <a:lstStyle/>
-          <a:p>
-            <a:pPr algn="ctr"/>
-          </a:p>
-        </p:txBody>
-      </p:sp>
-      <p:sp>
-        <p:nvSpPr>
-          <p:cNvPr id="11" name="TextBox 10"/>
-          <p:cNvSpPr txBox="1"/>
-          <p:nvPr/>
-        </p:nvSpPr>
-        <p:spPr>
-          <a:xfrm>
-            <a:off x="6400800" y="2286000"/>
-            <a:ext cx="4937760" cy="1554480"/>
-          </a:xfrm>
-          <a:prstGeom prst="rect">
-            <a:avLst/>
-          </a:prstGeom>
-          <a:noFill/>
-        </p:spPr>
-        <p:txBody>
-          <a:bodyPr wrap="square" anchor="ctr" lIns="0" tIns="0" rIns="0" bIns="0">
-            <a:spAutoFit/>
-          </a:bodyPr>
-          <a:lstStyle/>
-          <a:p>
-            <a:pPr algn="l">
-              <a:defRPr sz="1400" b="1">
-                <a:solidFill>
-                  <a:srgbClr val="11385B"/>
-                </a:solidFill>
-                <a:latin typeface="Arial"/>
-              </a:defRPr>
-            </a:pPr>
-            <a:r>
-              <a:t>Future scope 1: Reinforcement Learning</a:t>
-            </a:r>
-          </a:p>
-          <a:p>
+              <a:t>P50 Latency: 26.3 ms (AI) vs 43.9 ms (RR)</a:t>
+            </a:r>
             <a:br/>
-            <a:pPr algn="l">
-              <a:lnSpc>
-                <a:spcPct val="125000"/>
-              </a:lnSpc>
-              <a:defRPr sz="1150">
-                <a:solidFill>
-                  <a:srgbClr val="1E293B"/>
-                </a:solidFill>
-                <a:latin typeface="Arial"/>
-              </a:defRPr>
-            </a:pPr>
-            <a:r>
-              <a:t>Implement online Contextual Bandits or Q-learning to adapt to gradual performance drift without batch retraining.</a:t>
+            <a:r>
+              <a:t>Mean Latency: 25.7 ms (AI) vs 52.6 ms (RR)</a:t>
+            </a:r>
+            <a:br/>
+            <a:r>
+              <a:t>Consistent low-jitter response profile.</a:t>
             </a:r>
           </a:p>
         </p:txBody>
@@ -7996,8 +8026,8 @@
         </p:nvSpPr>
         <p:spPr>
           <a:xfrm>
-            <a:off x="594360" y="4251960"/>
-            <a:ext cx="5303520" cy="1920240"/>
+            <a:off x="8092440" y="1920240"/>
+            <a:ext cx="3474720" cy="1828800"/>
           </a:xfrm>
           <a:prstGeom prst="roundRect">
             <a:avLst/>
@@ -8041,8 +8071,8 @@
         </p:nvSpPr>
         <p:spPr>
           <a:xfrm>
-            <a:off x="777240" y="4434840"/>
-            <a:ext cx="4937760" cy="1554480"/>
+            <a:off x="8275320" y="2103120"/>
+            <a:ext cx="3108960" cy="1463040"/>
           </a:xfrm>
           <a:prstGeom prst="rect">
             <a:avLst/>
@@ -8055,7 +8085,7 @@
           </a:bodyPr>
           <a:lstStyle/>
           <a:p>
-            <a:pPr algn="l">
+            <a:pPr algn="ctr">
               <a:defRPr sz="1400" b="1">
                 <a:solidFill>
                   <a:srgbClr val="11385B"/>
@@ -8064,12 +8094,12 @@
               </a:defRPr>
             </a:pPr>
             <a:r>
-              <a:t>Future scope 2: Multi-Region Geolocation</a:t>
+              <a:t>Straggler Avoidance &amp; CDF</a:t>
             </a:r>
           </a:p>
           <a:p>
             <a:br/>
-            <a:pPr algn="l">
+            <a:pPr algn="ctr">
               <a:lnSpc>
                 <a:spcPct val="125000"/>
               </a:lnSpc>
@@ -8081,109 +8111,63 @@
               </a:defRPr>
             </a:pPr>
             <a:r>
-              <a:t>Extend feature vectors to factor in cross-region WAN transit costs, Geo-IP latency, and egress bandwidth limits.</a:t>
-            </a:r>
-          </a:p>
-        </p:txBody>
-      </p:sp>
-      <p:sp>
-        <p:nvSpPr>
-          <p:cNvPr id="14" name="Rounded Rectangle 13"/>
-          <p:cNvSpPr/>
-          <p:nvPr/>
-        </p:nvSpPr>
-        <p:spPr>
-          <a:xfrm>
-            <a:off x="6217920" y="4251960"/>
-            <a:ext cx="5303520" cy="1920240"/>
-          </a:xfrm>
-          <a:prstGeom prst="roundRect">
-            <a:avLst/>
-          </a:prstGeom>
-          <a:solidFill>
-            <a:srgbClr val="F0FDF4"/>
-          </a:solidFill>
-          <a:ln w="12700">
-            <a:solidFill>
-              <a:srgbClr val="CBD5E1"/>
-            </a:solidFill>
-          </a:ln>
-        </p:spPr>
-        <p:style>
-          <a:lnRef idx="1">
-            <a:schemeClr val="accent1"/>
-          </a:lnRef>
-          <a:fillRef idx="3">
-            <a:schemeClr val="accent1"/>
-          </a:fillRef>
-          <a:effectRef idx="2">
-            <a:schemeClr val="accent1"/>
-          </a:effectRef>
-          <a:fontRef idx="minor">
-            <a:schemeClr val="lt1"/>
-          </a:fontRef>
-        </p:style>
-        <p:txBody>
-          <a:bodyPr rtlCol="0" anchor="ctr"/>
-          <a:lstStyle/>
-          <a:p>
-            <a:pPr algn="ctr"/>
-          </a:p>
-        </p:txBody>
-      </p:sp>
-      <p:sp>
-        <p:nvSpPr>
-          <p:cNvPr id="15" name="TextBox 14"/>
-          <p:cNvSpPr txBox="1"/>
-          <p:nvPr/>
-        </p:nvSpPr>
-        <p:spPr>
-          <a:xfrm>
-            <a:off x="6400800" y="4434840"/>
-            <a:ext cx="4937760" cy="1554480"/>
-          </a:xfrm>
-          <a:prstGeom prst="rect">
-            <a:avLst/>
-          </a:prstGeom>
-          <a:noFill/>
-        </p:spPr>
-        <p:txBody>
-          <a:bodyPr wrap="square" anchor="ctr" lIns="0" tIns="0" rIns="0" bIns="0">
-            <a:spAutoFit/>
-          </a:bodyPr>
-          <a:lstStyle/>
-          <a:p>
-            <a:pPr algn="l">
-              <a:defRPr sz="1400" b="1">
-                <a:solidFill>
-                  <a:srgbClr val="11385B"/>
-                </a:solidFill>
-                <a:latin typeface="Arial"/>
-              </a:defRPr>
-            </a:pPr>
-            <a:r>
-              <a:t>Future scope 3: Kernel eBPF / XDP Bypass</a:t>
-            </a:r>
-          </a:p>
-          <a:p>
+              <a:t>Worker B (60ms slow node) avoided 100% of the time under AI.</a:t>
+            </a:r>
             <a:br/>
-            <a:pPr algn="l">
-              <a:lnSpc>
-                <a:spcPct val="125000"/>
-              </a:lnSpc>
-              <a:defRPr sz="1150">
-                <a:solidFill>
-                  <a:srgbClr val="1E293B"/>
-                </a:solidFill>
-                <a:latin typeface="Arial"/>
-              </a:defRPr>
-            </a:pPr>
-            <a:r>
-              <a:t>Execute packet steering directly inside the Linux kernel via eBPF/XDP, eliminating user-space memory copies for sub-microsecond routing.</a:t>
-            </a:r>
-          </a:p>
-        </p:txBody>
-      </p:sp>
+            <a:r>
+              <a:t>CDF curve demonstrates severe tail suppression (Dean &amp; Barroso 2013).</a:t>
+            </a:r>
+          </a:p>
+        </p:txBody>
+      </p:sp>
+      <p:pic>
+        <p:nvPicPr>
+          <p:cNvPr id="14" name="Picture 13" descr="shootout_5way_comparison.png"/>
+          <p:cNvPicPr>
+            <a:picLocks noChangeAspect="1"/>
+          </p:cNvPicPr>
+          <p:nvPr/>
+        </p:nvPicPr>
+        <p:blipFill>
+          <a:blip r:embed="rId4"/>
+          <a:stretch>
+            <a:fillRect/>
+          </a:stretch>
+        </p:blipFill>
+        <p:spPr>
+          <a:xfrm>
+            <a:off x="594360" y="3931920"/>
+            <a:ext cx="5303520" cy="2651760"/>
+          </a:xfrm>
+          <a:prstGeom prst="rect">
+            <a:avLst/>
+          </a:prstGeom>
+        </p:spPr>
+      </p:pic>
+      <p:pic>
+        <p:nvPicPr>
+          <p:cNvPr id="15" name="Picture 14" descr="cdf_latency_curve.png"/>
+          <p:cNvPicPr>
+            <a:picLocks noChangeAspect="1"/>
+          </p:cNvPicPr>
+          <p:nvPr/>
+        </p:nvPicPr>
+        <p:blipFill>
+          <a:blip r:embed="rId5"/>
+          <a:stretch>
+            <a:fillRect/>
+          </a:stretch>
+        </p:blipFill>
+        <p:spPr>
+          <a:xfrm>
+            <a:off x="6172200" y="3931920"/>
+            <a:ext cx="5394960" cy="2997200"/>
+          </a:xfrm>
+          <a:prstGeom prst="rect">
+            <a:avLst/>
+          </a:prstGeom>
+        </p:spPr>
+      </p:pic>
     </p:spTree>
   </p:cSld>
   <p:clrMapOvr>
@@ -8281,7 +8265,7 @@
               </a:defRPr>
             </a:pPr>
             <a:r>
-              <a:t>References</a:t>
+              <a:t>Advantages, Limitations and Applications</a:t>
             </a:r>
           </a:p>
         </p:txBody>
@@ -8317,7 +8301,7 @@
               </a:defRPr>
             </a:pPr>
             <a:r>
-              <a:t>Suggested sources to cite in the final report</a:t>
+              <a:t>What the project can and cannot do</a:t>
             </a:r>
           </a:p>
         </p:txBody>
@@ -8479,7 +8463,7 @@
               </a:defRPr>
             </a:pPr>
             <a:r>
-              <a:t>Academic Literature</a:t>
+              <a:t>Advantages</a:t>
             </a:r>
           </a:p>
           <a:p>
@@ -8496,11 +8480,7 @@
               </a:defRPr>
             </a:pPr>
             <a:r>
-              <a:t>Dean, J. &amp; Barroso, L. A. (2013). 'The Tail at Scale', Communications of the ACM, 56(2), 74-80.</a:t>
-            </a:r>
-            <a:br/>
-            <a:r>
-              <a:t>Alizadeh et al. (2014). 'CONGA: Distributed Congestion-Aware Load Balancing'.</a:t>
+              <a:t>Automated straggler detection, 63% tail latency reduction, zero-downtime fallback to Least Connections, and complete model explainability.</a:t>
             </a:r>
           </a:p>
         </p:txBody>
@@ -8581,7 +8561,7 @@
               </a:defRPr>
             </a:pPr>
             <a:r>
-              <a:t>Machine Learning &amp; Data Science</a:t>
+              <a:t>Limitations</a:t>
             </a:r>
           </a:p>
           <a:p>
@@ -8598,11 +8578,7 @@
               </a:defRPr>
             </a:pPr>
             <a:r>
-              <a:t>Pedregosa et al. (2011). 'Scikit-learn: Machine Learning in Python', Journal of Machine Learning Research.</a:t>
-            </a:r>
-            <a:br/>
-            <a:r>
-              <a:t>Breiman, L. (2001). 'Random Forests', Machine Learning, 45(1), 5-32.</a:t>
+              <a:t>Incurs ~1.5ms ML inference tax; requires initial training calibration samples (~20 decisions) before model can activate.</a:t>
             </a:r>
           </a:p>
         </p:txBody>
@@ -8683,7 +8659,7 @@
               </a:defRPr>
             </a:pPr>
             <a:r>
-              <a:t>Networking Standards &amp; Protocols</a:t>
+              <a:t>Applications</a:t>
             </a:r>
           </a:p>
           <a:p>
@@ -8700,11 +8676,7 @@
               </a:defRPr>
             </a:pPr>
             <a:r>
-              <a:t>Fielding, R. et al. (2022). RFC 9110: HTTP Semantics, Internet Engineering Task Force (IETF).</a:t>
-            </a:r>
-            <a:br/>
-            <a:r>
-              <a:t>HAProxy Technologies (2024). 'Dynamic Weight and Queue Load Balancing Whitepaper'.</a:t>
+              <a:t>Enterprise microservice meshes, cloud API gateways, financial low-latency trading feeds, and heterogeneous server clusters.</a:t>
             </a:r>
           </a:p>
         </p:txBody>
@@ -8785,7 +8757,7 @@
               </a:defRPr>
             </a:pPr>
             <a:r>
-              <a:t>Project Repository &amp; Deliverables</a:t>
+              <a:t>Ethics &amp; Operational Security</a:t>
             </a:r>
           </a:p>
           <a:p>
@@ -8802,11 +8774,618 @@
               </a:defRPr>
             </a:pPr>
             <a:r>
-              <a:t>Source code repository: github.com/Krishna-Modi12/ai-based-load-balancing</a:t>
-            </a:r>
+              <a:t>Strict administrative token protection, private header preservation, bounded timeouts, and transparent feature attribution.</a:t>
+            </a:r>
+          </a:p>
+        </p:txBody>
+      </p:sp>
+    </p:spTree>
+  </p:cSld>
+  <p:clrMapOvr>
+    <a:masterClrMapping/>
+  </p:clrMapOvr>
+</p:sld>
+</file>
+
+<file path=ppt/slides/slide19.xml><?xml version="1.0" encoding="utf-8"?>
+<p:sld xmlns:a="http://schemas.openxmlformats.org/drawingml/2006/main" xmlns:p="http://schemas.openxmlformats.org/presentationml/2006/main" xmlns:r="http://schemas.openxmlformats.org/officeDocument/2006/relationships">
+  <p:cSld>
+    <p:spTree>
+      <p:nvGrpSpPr>
+        <p:cNvPr id="1" name=""/>
+        <p:cNvGrpSpPr/>
+        <p:nvPr/>
+      </p:nvGrpSpPr>
+      <p:grpSpPr/>
+      <p:pic>
+        <p:nvPicPr>
+          <p:cNvPr id="2" name="Picture 1" descr="logo_1.jpeg"/>
+          <p:cNvPicPr>
+            <a:picLocks noChangeAspect="1"/>
+          </p:cNvPicPr>
+          <p:nvPr/>
+        </p:nvPicPr>
+        <p:blipFill>
+          <a:blip r:embed="rId2"/>
+          <a:stretch>
+            <a:fillRect/>
+          </a:stretch>
+        </p:blipFill>
+        <p:spPr>
+          <a:xfrm>
+            <a:off x="457200" y="164592"/>
+            <a:ext cx="2194560" cy="757292"/>
+          </a:xfrm>
+          <a:prstGeom prst="rect">
+            <a:avLst/>
+          </a:prstGeom>
+        </p:spPr>
+      </p:pic>
+      <p:pic>
+        <p:nvPicPr>
+          <p:cNvPr id="3" name="Picture 2" descr="logo_2.jpeg"/>
+          <p:cNvPicPr>
+            <a:picLocks noChangeAspect="1"/>
+          </p:cNvPicPr>
+          <p:nvPr/>
+        </p:nvPicPr>
+        <p:blipFill>
+          <a:blip r:embed="rId3"/>
+          <a:stretch>
+            <a:fillRect/>
+          </a:stretch>
+        </p:blipFill>
+        <p:spPr>
+          <a:xfrm>
+            <a:off x="10607040" y="164592"/>
+            <a:ext cx="1097280" cy="599616"/>
+          </a:xfrm>
+          <a:prstGeom prst="rect">
+            <a:avLst/>
+          </a:prstGeom>
+        </p:spPr>
+      </p:pic>
+      <p:sp>
+        <p:nvSpPr>
+          <p:cNvPr id="4" name="TextBox 3"/>
+          <p:cNvSpPr txBox="1"/>
+          <p:nvPr/>
+        </p:nvSpPr>
+        <p:spPr>
+          <a:xfrm>
+            <a:off x="548640" y="960120"/>
+            <a:ext cx="11094415" cy="457200"/>
+          </a:xfrm>
+          <a:prstGeom prst="rect">
+            <a:avLst/>
+          </a:prstGeom>
+          <a:noFill/>
+        </p:spPr>
+        <p:txBody>
+          <a:bodyPr wrap="square" lIns="0" tIns="0" rIns="0" bIns="0">
+            <a:spAutoFit/>
+          </a:bodyPr>
+          <a:lstStyle/>
+          <a:p>
+            <a:pPr>
+              <a:defRPr sz="2200" b="1">
+                <a:solidFill>
+                  <a:srgbClr val="11385B"/>
+                </a:solidFill>
+                <a:latin typeface="Arial"/>
+              </a:defRPr>
+            </a:pPr>
+            <a:r>
+              <a:t>Conclusion and Future Scope</a:t>
+            </a:r>
+          </a:p>
+        </p:txBody>
+      </p:sp>
+      <p:sp>
+        <p:nvSpPr>
+          <p:cNvPr id="5" name="TextBox 4"/>
+          <p:cNvSpPr txBox="1"/>
+          <p:nvPr/>
+        </p:nvSpPr>
+        <p:spPr>
+          <a:xfrm>
+            <a:off x="548640" y="1417320"/>
+            <a:ext cx="11094415" cy="274320"/>
+          </a:xfrm>
+          <a:prstGeom prst="rect">
+            <a:avLst/>
+          </a:prstGeom>
+          <a:noFill/>
+        </p:spPr>
+        <p:txBody>
+          <a:bodyPr wrap="square" lIns="0" tIns="0" rIns="0" bIns="0">
+            <a:spAutoFit/>
+          </a:bodyPr>
+          <a:lstStyle/>
+          <a:p>
+            <a:pPr>
+              <a:defRPr sz="1100" i="1">
+                <a:solidFill>
+                  <a:srgbClr val="64748B"/>
+                </a:solidFill>
+                <a:latin typeface="Arial"/>
+              </a:defRPr>
+            </a:pPr>
+            <a:r>
+              <a:t>Summary and improvements</a:t>
+            </a:r>
+          </a:p>
+        </p:txBody>
+      </p:sp>
+      <p:sp>
+        <p:nvSpPr>
+          <p:cNvPr id="6" name="Rectangle 5"/>
+          <p:cNvSpPr/>
+          <p:nvPr/>
+        </p:nvSpPr>
+        <p:spPr>
+          <a:xfrm>
+            <a:off x="548640" y="1783080"/>
+            <a:ext cx="11094415" cy="36576"/>
+          </a:xfrm>
+          <a:prstGeom prst="rect">
+            <a:avLst/>
+          </a:prstGeom>
+          <a:solidFill>
+            <a:srgbClr val="B91C1C"/>
+          </a:solidFill>
+          <a:ln>
+            <a:solidFill>
+              <a:srgbClr val="B91C1C"/>
+            </a:solidFill>
+          </a:ln>
+        </p:spPr>
+        <p:style>
+          <a:lnRef idx="1">
+            <a:schemeClr val="accent1"/>
+          </a:lnRef>
+          <a:fillRef idx="3">
+            <a:schemeClr val="accent1"/>
+          </a:fillRef>
+          <a:effectRef idx="2">
+            <a:schemeClr val="accent1"/>
+          </a:effectRef>
+          <a:fontRef idx="minor">
+            <a:schemeClr val="lt1"/>
+          </a:fontRef>
+        </p:style>
+        <p:txBody>
+          <a:bodyPr rtlCol="0" anchor="ctr"/>
+          <a:lstStyle/>
+          <a:p>
+            <a:pPr algn="ctr"/>
+          </a:p>
+        </p:txBody>
+      </p:sp>
+      <p:sp>
+        <p:nvSpPr>
+          <p:cNvPr id="7" name="TextBox 6"/>
+          <p:cNvSpPr txBox="1"/>
+          <p:nvPr/>
+        </p:nvSpPr>
+        <p:spPr>
+          <a:xfrm>
+            <a:off x="6858000" y="6492240"/>
+            <a:ext cx="4754880" cy="274320"/>
+          </a:xfrm>
+          <a:prstGeom prst="rect">
+            <a:avLst/>
+          </a:prstGeom>
+          <a:noFill/>
+        </p:spPr>
+        <p:txBody>
+          <a:bodyPr wrap="square" lIns="0" tIns="0" rIns="0" bIns="0">
+            <a:spAutoFit/>
+          </a:bodyPr>
+          <a:lstStyle/>
+          <a:p>
+            <a:pPr algn="r">
+              <a:defRPr sz="850">
+                <a:solidFill>
+                  <a:srgbClr val="64748B"/>
+                </a:solidFill>
+                <a:latin typeface="Arial"/>
+              </a:defRPr>
+            </a:pPr>
+            <a:r>
+              <a:t>COMPUTER NETWORKS | AI-BASED MINI PROJECT</a:t>
+            </a:r>
+          </a:p>
+        </p:txBody>
+      </p:sp>
+      <p:sp>
+        <p:nvSpPr>
+          <p:cNvPr id="8" name="Rounded Rectangle 7"/>
+          <p:cNvSpPr/>
+          <p:nvPr/>
+        </p:nvSpPr>
+        <p:spPr>
+          <a:xfrm>
+            <a:off x="594360" y="2103120"/>
+            <a:ext cx="5303520" cy="1920240"/>
+          </a:xfrm>
+          <a:prstGeom prst="roundRect">
+            <a:avLst/>
+          </a:prstGeom>
+          <a:solidFill>
+            <a:srgbClr val="F0F9FF"/>
+          </a:solidFill>
+          <a:ln w="12700">
+            <a:solidFill>
+              <a:srgbClr val="CBD5E1"/>
+            </a:solidFill>
+          </a:ln>
+        </p:spPr>
+        <p:style>
+          <a:lnRef idx="1">
+            <a:schemeClr val="accent1"/>
+          </a:lnRef>
+          <a:fillRef idx="3">
+            <a:schemeClr val="accent1"/>
+          </a:fillRef>
+          <a:effectRef idx="2">
+            <a:schemeClr val="accent1"/>
+          </a:effectRef>
+          <a:fontRef idx="minor">
+            <a:schemeClr val="lt1"/>
+          </a:fontRef>
+        </p:style>
+        <p:txBody>
+          <a:bodyPr rtlCol="0" anchor="ctr"/>
+          <a:lstStyle/>
+          <a:p>
+            <a:pPr algn="ctr"/>
+          </a:p>
+        </p:txBody>
+      </p:sp>
+      <p:sp>
+        <p:nvSpPr>
+          <p:cNvPr id="9" name="TextBox 8"/>
+          <p:cNvSpPr txBox="1"/>
+          <p:nvPr/>
+        </p:nvSpPr>
+        <p:spPr>
+          <a:xfrm>
+            <a:off x="777240" y="2286000"/>
+            <a:ext cx="4937760" cy="1554480"/>
+          </a:xfrm>
+          <a:prstGeom prst="rect">
+            <a:avLst/>
+          </a:prstGeom>
+          <a:noFill/>
+        </p:spPr>
+        <p:txBody>
+          <a:bodyPr wrap="square" anchor="ctr" lIns="0" tIns="0" rIns="0" bIns="0">
+            <a:spAutoFit/>
+          </a:bodyPr>
+          <a:lstStyle/>
+          <a:p>
+            <a:pPr algn="l">
+              <a:defRPr sz="1400" b="1">
+                <a:solidFill>
+                  <a:srgbClr val="11385B"/>
+                </a:solidFill>
+                <a:latin typeface="Arial"/>
+              </a:defRPr>
+            </a:pPr>
+            <a:r>
+              <a:t>Conclusion</a:t>
+            </a:r>
+          </a:p>
+          <a:p>
             <a:br/>
-            <a:r>
-              <a:t>Includes full test suite (26 passed), Docker Compose environment, and live React HUD.</a:t>
+            <a:pPr algn="l">
+              <a:lnSpc>
+                <a:spcPct val="125000"/>
+              </a:lnSpc>
+              <a:defRPr sz="1150">
+                <a:solidFill>
+                  <a:srgbClr val="1E293B"/>
+                </a:solidFill>
+                <a:latin typeface="Arial"/>
+              </a:defRPr>
+            </a:pPr>
+            <a:r>
+              <a:t>The prototype successfully proves that supervised machine learning significantly outperforms static heuristics in heterogeneous cloud networks.</a:t>
+            </a:r>
+          </a:p>
+        </p:txBody>
+      </p:sp>
+      <p:sp>
+        <p:nvSpPr>
+          <p:cNvPr id="10" name="Rounded Rectangle 9"/>
+          <p:cNvSpPr/>
+          <p:nvPr/>
+        </p:nvSpPr>
+        <p:spPr>
+          <a:xfrm>
+            <a:off x="6217920" y="2103120"/>
+            <a:ext cx="5303520" cy="1920240"/>
+          </a:xfrm>
+          <a:prstGeom prst="roundRect">
+            <a:avLst/>
+          </a:prstGeom>
+          <a:solidFill>
+            <a:srgbClr val="FFF1F2"/>
+          </a:solidFill>
+          <a:ln w="12700">
+            <a:solidFill>
+              <a:srgbClr val="CBD5E1"/>
+            </a:solidFill>
+          </a:ln>
+        </p:spPr>
+        <p:style>
+          <a:lnRef idx="1">
+            <a:schemeClr val="accent1"/>
+          </a:lnRef>
+          <a:fillRef idx="3">
+            <a:schemeClr val="accent1"/>
+          </a:fillRef>
+          <a:effectRef idx="2">
+            <a:schemeClr val="accent1"/>
+          </a:effectRef>
+          <a:fontRef idx="minor">
+            <a:schemeClr val="lt1"/>
+          </a:fontRef>
+        </p:style>
+        <p:txBody>
+          <a:bodyPr rtlCol="0" anchor="ctr"/>
+          <a:lstStyle/>
+          <a:p>
+            <a:pPr algn="ctr"/>
+          </a:p>
+        </p:txBody>
+      </p:sp>
+      <p:sp>
+        <p:nvSpPr>
+          <p:cNvPr id="11" name="TextBox 10"/>
+          <p:cNvSpPr txBox="1"/>
+          <p:nvPr/>
+        </p:nvSpPr>
+        <p:spPr>
+          <a:xfrm>
+            <a:off x="6400800" y="2286000"/>
+            <a:ext cx="4937760" cy="1554480"/>
+          </a:xfrm>
+          <a:prstGeom prst="rect">
+            <a:avLst/>
+          </a:prstGeom>
+          <a:noFill/>
+        </p:spPr>
+        <p:txBody>
+          <a:bodyPr wrap="square" anchor="ctr" lIns="0" tIns="0" rIns="0" bIns="0">
+            <a:spAutoFit/>
+          </a:bodyPr>
+          <a:lstStyle/>
+          <a:p>
+            <a:pPr algn="l">
+              <a:defRPr sz="1400" b="1">
+                <a:solidFill>
+                  <a:srgbClr val="11385B"/>
+                </a:solidFill>
+                <a:latin typeface="Arial"/>
+              </a:defRPr>
+            </a:pPr>
+            <a:r>
+              <a:t>Future scope 1: Reinforcement Learning</a:t>
+            </a:r>
+          </a:p>
+          <a:p>
+            <a:br/>
+            <a:pPr algn="l">
+              <a:lnSpc>
+                <a:spcPct val="125000"/>
+              </a:lnSpc>
+              <a:defRPr sz="1150">
+                <a:solidFill>
+                  <a:srgbClr val="1E293B"/>
+                </a:solidFill>
+                <a:latin typeface="Arial"/>
+              </a:defRPr>
+            </a:pPr>
+            <a:r>
+              <a:t>Implement online Contextual Bandits or Q-learning to adapt to gradual performance drift without batch retraining.</a:t>
+            </a:r>
+          </a:p>
+        </p:txBody>
+      </p:sp>
+      <p:sp>
+        <p:nvSpPr>
+          <p:cNvPr id="12" name="Rounded Rectangle 11"/>
+          <p:cNvSpPr/>
+          <p:nvPr/>
+        </p:nvSpPr>
+        <p:spPr>
+          <a:xfrm>
+            <a:off x="594360" y="4251960"/>
+            <a:ext cx="5303520" cy="1920240"/>
+          </a:xfrm>
+          <a:prstGeom prst="roundRect">
+            <a:avLst/>
+          </a:prstGeom>
+          <a:solidFill>
+            <a:srgbClr val="F5F3FF"/>
+          </a:solidFill>
+          <a:ln w="12700">
+            <a:solidFill>
+              <a:srgbClr val="CBD5E1"/>
+            </a:solidFill>
+          </a:ln>
+        </p:spPr>
+        <p:style>
+          <a:lnRef idx="1">
+            <a:schemeClr val="accent1"/>
+          </a:lnRef>
+          <a:fillRef idx="3">
+            <a:schemeClr val="accent1"/>
+          </a:fillRef>
+          <a:effectRef idx="2">
+            <a:schemeClr val="accent1"/>
+          </a:effectRef>
+          <a:fontRef idx="minor">
+            <a:schemeClr val="lt1"/>
+          </a:fontRef>
+        </p:style>
+        <p:txBody>
+          <a:bodyPr rtlCol="0" anchor="ctr"/>
+          <a:lstStyle/>
+          <a:p>
+            <a:pPr algn="ctr"/>
+          </a:p>
+        </p:txBody>
+      </p:sp>
+      <p:sp>
+        <p:nvSpPr>
+          <p:cNvPr id="13" name="TextBox 12"/>
+          <p:cNvSpPr txBox="1"/>
+          <p:nvPr/>
+        </p:nvSpPr>
+        <p:spPr>
+          <a:xfrm>
+            <a:off x="777240" y="4434840"/>
+            <a:ext cx="4937760" cy="1554480"/>
+          </a:xfrm>
+          <a:prstGeom prst="rect">
+            <a:avLst/>
+          </a:prstGeom>
+          <a:noFill/>
+        </p:spPr>
+        <p:txBody>
+          <a:bodyPr wrap="square" anchor="ctr" lIns="0" tIns="0" rIns="0" bIns="0">
+            <a:spAutoFit/>
+          </a:bodyPr>
+          <a:lstStyle/>
+          <a:p>
+            <a:pPr algn="l">
+              <a:defRPr sz="1400" b="1">
+                <a:solidFill>
+                  <a:srgbClr val="11385B"/>
+                </a:solidFill>
+                <a:latin typeface="Arial"/>
+              </a:defRPr>
+            </a:pPr>
+            <a:r>
+              <a:t>Future scope 2: Multi-Region Geolocation</a:t>
+            </a:r>
+          </a:p>
+          <a:p>
+            <a:br/>
+            <a:pPr algn="l">
+              <a:lnSpc>
+                <a:spcPct val="125000"/>
+              </a:lnSpc>
+              <a:defRPr sz="1150">
+                <a:solidFill>
+                  <a:srgbClr val="1E293B"/>
+                </a:solidFill>
+                <a:latin typeface="Arial"/>
+              </a:defRPr>
+            </a:pPr>
+            <a:r>
+              <a:t>Extend feature vectors to factor in cross-region WAN transit costs, Geo-IP latency, and egress bandwidth limits.</a:t>
+            </a:r>
+          </a:p>
+        </p:txBody>
+      </p:sp>
+      <p:sp>
+        <p:nvSpPr>
+          <p:cNvPr id="14" name="Rounded Rectangle 13"/>
+          <p:cNvSpPr/>
+          <p:nvPr/>
+        </p:nvSpPr>
+        <p:spPr>
+          <a:xfrm>
+            <a:off x="6217920" y="4251960"/>
+            <a:ext cx="5303520" cy="1920240"/>
+          </a:xfrm>
+          <a:prstGeom prst="roundRect">
+            <a:avLst/>
+          </a:prstGeom>
+          <a:solidFill>
+            <a:srgbClr val="F0FDF4"/>
+          </a:solidFill>
+          <a:ln w="12700">
+            <a:solidFill>
+              <a:srgbClr val="CBD5E1"/>
+            </a:solidFill>
+          </a:ln>
+        </p:spPr>
+        <p:style>
+          <a:lnRef idx="1">
+            <a:schemeClr val="accent1"/>
+          </a:lnRef>
+          <a:fillRef idx="3">
+            <a:schemeClr val="accent1"/>
+          </a:fillRef>
+          <a:effectRef idx="2">
+            <a:schemeClr val="accent1"/>
+          </a:effectRef>
+          <a:fontRef idx="minor">
+            <a:schemeClr val="lt1"/>
+          </a:fontRef>
+        </p:style>
+        <p:txBody>
+          <a:bodyPr rtlCol="0" anchor="ctr"/>
+          <a:lstStyle/>
+          <a:p>
+            <a:pPr algn="ctr"/>
+          </a:p>
+        </p:txBody>
+      </p:sp>
+      <p:sp>
+        <p:nvSpPr>
+          <p:cNvPr id="15" name="TextBox 14"/>
+          <p:cNvSpPr txBox="1"/>
+          <p:nvPr/>
+        </p:nvSpPr>
+        <p:spPr>
+          <a:xfrm>
+            <a:off x="6400800" y="4434840"/>
+            <a:ext cx="4937760" cy="1554480"/>
+          </a:xfrm>
+          <a:prstGeom prst="rect">
+            <a:avLst/>
+          </a:prstGeom>
+          <a:noFill/>
+        </p:spPr>
+        <p:txBody>
+          <a:bodyPr wrap="square" anchor="ctr" lIns="0" tIns="0" rIns="0" bIns="0">
+            <a:spAutoFit/>
+          </a:bodyPr>
+          <a:lstStyle/>
+          <a:p>
+            <a:pPr algn="l">
+              <a:defRPr sz="1400" b="1">
+                <a:solidFill>
+                  <a:srgbClr val="11385B"/>
+                </a:solidFill>
+                <a:latin typeface="Arial"/>
+              </a:defRPr>
+            </a:pPr>
+            <a:r>
+              <a:t>Future scope 3: Kernel eBPF / XDP Bypass</a:t>
+            </a:r>
+          </a:p>
+          <a:p>
+            <a:br/>
+            <a:pPr algn="l">
+              <a:lnSpc>
+                <a:spcPct val="125000"/>
+              </a:lnSpc>
+              <a:defRPr sz="1150">
+                <a:solidFill>
+                  <a:srgbClr val="1E293B"/>
+                </a:solidFill>
+                <a:latin typeface="Arial"/>
+              </a:defRPr>
+            </a:pPr>
+            <a:r>
+              <a:t>Execute packet steering directly inside the Linux kernel via eBPF/XDP, eliminating user-space memory copies for sub-microsecond routing.</a:t>
             </a:r>
           </a:p>
         </p:txBody>
@@ -9072,6 +9651,633 @@
             </a:pPr>
             <a:r>
               <a:t>•  Which Computer Networks syllabus units are most directly demonstrated in this end-to-end implementation?</a:t>
+            </a:r>
+          </a:p>
+        </p:txBody>
+      </p:sp>
+    </p:spTree>
+  </p:cSld>
+  <p:clrMapOvr>
+    <a:masterClrMapping/>
+  </p:clrMapOvr>
+</p:sld>
+</file>
+
+<file path=ppt/slides/slide20.xml><?xml version="1.0" encoding="utf-8"?>
+<p:sld xmlns:a="http://schemas.openxmlformats.org/drawingml/2006/main" xmlns:p="http://schemas.openxmlformats.org/presentationml/2006/main" xmlns:r="http://schemas.openxmlformats.org/officeDocument/2006/relationships">
+  <p:cSld>
+    <p:spTree>
+      <p:nvGrpSpPr>
+        <p:cNvPr id="1" name=""/>
+        <p:cNvGrpSpPr/>
+        <p:nvPr/>
+      </p:nvGrpSpPr>
+      <p:grpSpPr/>
+      <p:pic>
+        <p:nvPicPr>
+          <p:cNvPr id="2" name="Picture 1" descr="logo_1.jpeg"/>
+          <p:cNvPicPr>
+            <a:picLocks noChangeAspect="1"/>
+          </p:cNvPicPr>
+          <p:nvPr/>
+        </p:nvPicPr>
+        <p:blipFill>
+          <a:blip r:embed="rId2"/>
+          <a:stretch>
+            <a:fillRect/>
+          </a:stretch>
+        </p:blipFill>
+        <p:spPr>
+          <a:xfrm>
+            <a:off x="457200" y="164592"/>
+            <a:ext cx="2194560" cy="757292"/>
+          </a:xfrm>
+          <a:prstGeom prst="rect">
+            <a:avLst/>
+          </a:prstGeom>
+        </p:spPr>
+      </p:pic>
+      <p:pic>
+        <p:nvPicPr>
+          <p:cNvPr id="3" name="Picture 2" descr="logo_2.jpeg"/>
+          <p:cNvPicPr>
+            <a:picLocks noChangeAspect="1"/>
+          </p:cNvPicPr>
+          <p:nvPr/>
+        </p:nvPicPr>
+        <p:blipFill>
+          <a:blip r:embed="rId3"/>
+          <a:stretch>
+            <a:fillRect/>
+          </a:stretch>
+        </p:blipFill>
+        <p:spPr>
+          <a:xfrm>
+            <a:off x="10607040" y="164592"/>
+            <a:ext cx="1097280" cy="599616"/>
+          </a:xfrm>
+          <a:prstGeom prst="rect">
+            <a:avLst/>
+          </a:prstGeom>
+        </p:spPr>
+      </p:pic>
+      <p:sp>
+        <p:nvSpPr>
+          <p:cNvPr id="4" name="TextBox 3"/>
+          <p:cNvSpPr txBox="1"/>
+          <p:nvPr/>
+        </p:nvSpPr>
+        <p:spPr>
+          <a:xfrm>
+            <a:off x="548640" y="960120"/>
+            <a:ext cx="11094415" cy="457200"/>
+          </a:xfrm>
+          <a:prstGeom prst="rect">
+            <a:avLst/>
+          </a:prstGeom>
+          <a:noFill/>
+        </p:spPr>
+        <p:txBody>
+          <a:bodyPr wrap="square" lIns="0" tIns="0" rIns="0" bIns="0">
+            <a:spAutoFit/>
+          </a:bodyPr>
+          <a:lstStyle/>
+          <a:p>
+            <a:pPr>
+              <a:defRPr sz="2200" b="1">
+                <a:solidFill>
+                  <a:srgbClr val="11385B"/>
+                </a:solidFill>
+                <a:latin typeface="Arial"/>
+              </a:defRPr>
+            </a:pPr>
+            <a:r>
+              <a:t>References</a:t>
+            </a:r>
+          </a:p>
+        </p:txBody>
+      </p:sp>
+      <p:sp>
+        <p:nvSpPr>
+          <p:cNvPr id="5" name="TextBox 4"/>
+          <p:cNvSpPr txBox="1"/>
+          <p:nvPr/>
+        </p:nvSpPr>
+        <p:spPr>
+          <a:xfrm>
+            <a:off x="548640" y="1417320"/>
+            <a:ext cx="11094415" cy="274320"/>
+          </a:xfrm>
+          <a:prstGeom prst="rect">
+            <a:avLst/>
+          </a:prstGeom>
+          <a:noFill/>
+        </p:spPr>
+        <p:txBody>
+          <a:bodyPr wrap="square" lIns="0" tIns="0" rIns="0" bIns="0">
+            <a:spAutoFit/>
+          </a:bodyPr>
+          <a:lstStyle/>
+          <a:p>
+            <a:pPr>
+              <a:defRPr sz="1100" i="1">
+                <a:solidFill>
+                  <a:srgbClr val="64748B"/>
+                </a:solidFill>
+                <a:latin typeface="Arial"/>
+              </a:defRPr>
+            </a:pPr>
+            <a:r>
+              <a:t>Suggested sources to cite in the final report</a:t>
+            </a:r>
+          </a:p>
+        </p:txBody>
+      </p:sp>
+      <p:sp>
+        <p:nvSpPr>
+          <p:cNvPr id="6" name="Rectangle 5"/>
+          <p:cNvSpPr/>
+          <p:nvPr/>
+        </p:nvSpPr>
+        <p:spPr>
+          <a:xfrm>
+            <a:off x="548640" y="1783080"/>
+            <a:ext cx="11094415" cy="36576"/>
+          </a:xfrm>
+          <a:prstGeom prst="rect">
+            <a:avLst/>
+          </a:prstGeom>
+          <a:solidFill>
+            <a:srgbClr val="B91C1C"/>
+          </a:solidFill>
+          <a:ln>
+            <a:solidFill>
+              <a:srgbClr val="B91C1C"/>
+            </a:solidFill>
+          </a:ln>
+        </p:spPr>
+        <p:style>
+          <a:lnRef idx="1">
+            <a:schemeClr val="accent1"/>
+          </a:lnRef>
+          <a:fillRef idx="3">
+            <a:schemeClr val="accent1"/>
+          </a:fillRef>
+          <a:effectRef idx="2">
+            <a:schemeClr val="accent1"/>
+          </a:effectRef>
+          <a:fontRef idx="minor">
+            <a:schemeClr val="lt1"/>
+          </a:fontRef>
+        </p:style>
+        <p:txBody>
+          <a:bodyPr rtlCol="0" anchor="ctr"/>
+          <a:lstStyle/>
+          <a:p>
+            <a:pPr algn="ctr"/>
+          </a:p>
+        </p:txBody>
+      </p:sp>
+      <p:sp>
+        <p:nvSpPr>
+          <p:cNvPr id="7" name="TextBox 6"/>
+          <p:cNvSpPr txBox="1"/>
+          <p:nvPr/>
+        </p:nvSpPr>
+        <p:spPr>
+          <a:xfrm>
+            <a:off x="6858000" y="6492240"/>
+            <a:ext cx="4754880" cy="274320"/>
+          </a:xfrm>
+          <a:prstGeom prst="rect">
+            <a:avLst/>
+          </a:prstGeom>
+          <a:noFill/>
+        </p:spPr>
+        <p:txBody>
+          <a:bodyPr wrap="square" lIns="0" tIns="0" rIns="0" bIns="0">
+            <a:spAutoFit/>
+          </a:bodyPr>
+          <a:lstStyle/>
+          <a:p>
+            <a:pPr algn="r">
+              <a:defRPr sz="850">
+                <a:solidFill>
+                  <a:srgbClr val="64748B"/>
+                </a:solidFill>
+                <a:latin typeface="Arial"/>
+              </a:defRPr>
+            </a:pPr>
+            <a:r>
+              <a:t>COMPUTER NETWORKS | AI-BASED MINI PROJECT</a:t>
+            </a:r>
+          </a:p>
+        </p:txBody>
+      </p:sp>
+      <p:sp>
+        <p:nvSpPr>
+          <p:cNvPr id="8" name="Rounded Rectangle 7"/>
+          <p:cNvSpPr/>
+          <p:nvPr/>
+        </p:nvSpPr>
+        <p:spPr>
+          <a:xfrm>
+            <a:off x="594360" y="2103120"/>
+            <a:ext cx="5303520" cy="1920240"/>
+          </a:xfrm>
+          <a:prstGeom prst="roundRect">
+            <a:avLst/>
+          </a:prstGeom>
+          <a:solidFill>
+            <a:srgbClr val="F0F9FF"/>
+          </a:solidFill>
+          <a:ln w="12700">
+            <a:solidFill>
+              <a:srgbClr val="CBD5E1"/>
+            </a:solidFill>
+          </a:ln>
+        </p:spPr>
+        <p:style>
+          <a:lnRef idx="1">
+            <a:schemeClr val="accent1"/>
+          </a:lnRef>
+          <a:fillRef idx="3">
+            <a:schemeClr val="accent1"/>
+          </a:fillRef>
+          <a:effectRef idx="2">
+            <a:schemeClr val="accent1"/>
+          </a:effectRef>
+          <a:fontRef idx="minor">
+            <a:schemeClr val="lt1"/>
+          </a:fontRef>
+        </p:style>
+        <p:txBody>
+          <a:bodyPr rtlCol="0" anchor="ctr"/>
+          <a:lstStyle/>
+          <a:p>
+            <a:pPr algn="ctr"/>
+          </a:p>
+        </p:txBody>
+      </p:sp>
+      <p:sp>
+        <p:nvSpPr>
+          <p:cNvPr id="9" name="TextBox 8"/>
+          <p:cNvSpPr txBox="1"/>
+          <p:nvPr/>
+        </p:nvSpPr>
+        <p:spPr>
+          <a:xfrm>
+            <a:off x="777240" y="2286000"/>
+            <a:ext cx="4937760" cy="1554480"/>
+          </a:xfrm>
+          <a:prstGeom prst="rect">
+            <a:avLst/>
+          </a:prstGeom>
+          <a:noFill/>
+        </p:spPr>
+        <p:txBody>
+          <a:bodyPr wrap="square" anchor="ctr" lIns="0" tIns="0" rIns="0" bIns="0">
+            <a:spAutoFit/>
+          </a:bodyPr>
+          <a:lstStyle/>
+          <a:p>
+            <a:pPr algn="l">
+              <a:defRPr sz="1400" b="1">
+                <a:solidFill>
+                  <a:srgbClr val="11385B"/>
+                </a:solidFill>
+                <a:latin typeface="Arial"/>
+              </a:defRPr>
+            </a:pPr>
+            <a:r>
+              <a:t>Academic Literature</a:t>
+            </a:r>
+          </a:p>
+          <a:p>
+            <a:br/>
+            <a:pPr algn="l">
+              <a:lnSpc>
+                <a:spcPct val="125000"/>
+              </a:lnSpc>
+              <a:defRPr sz="1150">
+                <a:solidFill>
+                  <a:srgbClr val="1E293B"/>
+                </a:solidFill>
+                <a:latin typeface="Arial"/>
+              </a:defRPr>
+            </a:pPr>
+            <a:r>
+              <a:t>Dean, J. &amp; Barroso, L. A. (2013). 'The Tail at Scale', Communications of the ACM, 56(2), 74-80.</a:t>
+            </a:r>
+            <a:br/>
+            <a:r>
+              <a:t>Alizadeh et al. (2014). 'CONGA: Distributed Congestion-Aware Load Balancing'.</a:t>
+            </a:r>
+          </a:p>
+        </p:txBody>
+      </p:sp>
+      <p:sp>
+        <p:nvSpPr>
+          <p:cNvPr id="10" name="Rounded Rectangle 9"/>
+          <p:cNvSpPr/>
+          <p:nvPr/>
+        </p:nvSpPr>
+        <p:spPr>
+          <a:xfrm>
+            <a:off x="6217920" y="2103120"/>
+            <a:ext cx="5303520" cy="1920240"/>
+          </a:xfrm>
+          <a:prstGeom prst="roundRect">
+            <a:avLst/>
+          </a:prstGeom>
+          <a:solidFill>
+            <a:srgbClr val="FFF1F2"/>
+          </a:solidFill>
+          <a:ln w="12700">
+            <a:solidFill>
+              <a:srgbClr val="CBD5E1"/>
+            </a:solidFill>
+          </a:ln>
+        </p:spPr>
+        <p:style>
+          <a:lnRef idx="1">
+            <a:schemeClr val="accent1"/>
+          </a:lnRef>
+          <a:fillRef idx="3">
+            <a:schemeClr val="accent1"/>
+          </a:fillRef>
+          <a:effectRef idx="2">
+            <a:schemeClr val="accent1"/>
+          </a:effectRef>
+          <a:fontRef idx="minor">
+            <a:schemeClr val="lt1"/>
+          </a:fontRef>
+        </p:style>
+        <p:txBody>
+          <a:bodyPr rtlCol="0" anchor="ctr"/>
+          <a:lstStyle/>
+          <a:p>
+            <a:pPr algn="ctr"/>
+          </a:p>
+        </p:txBody>
+      </p:sp>
+      <p:sp>
+        <p:nvSpPr>
+          <p:cNvPr id="11" name="TextBox 10"/>
+          <p:cNvSpPr txBox="1"/>
+          <p:nvPr/>
+        </p:nvSpPr>
+        <p:spPr>
+          <a:xfrm>
+            <a:off x="6400800" y="2286000"/>
+            <a:ext cx="4937760" cy="1554480"/>
+          </a:xfrm>
+          <a:prstGeom prst="rect">
+            <a:avLst/>
+          </a:prstGeom>
+          <a:noFill/>
+        </p:spPr>
+        <p:txBody>
+          <a:bodyPr wrap="square" anchor="ctr" lIns="0" tIns="0" rIns="0" bIns="0">
+            <a:spAutoFit/>
+          </a:bodyPr>
+          <a:lstStyle/>
+          <a:p>
+            <a:pPr algn="l">
+              <a:defRPr sz="1400" b="1">
+                <a:solidFill>
+                  <a:srgbClr val="11385B"/>
+                </a:solidFill>
+                <a:latin typeface="Arial"/>
+              </a:defRPr>
+            </a:pPr>
+            <a:r>
+              <a:t>Machine Learning &amp; Data Science</a:t>
+            </a:r>
+          </a:p>
+          <a:p>
+            <a:br/>
+            <a:pPr algn="l">
+              <a:lnSpc>
+                <a:spcPct val="125000"/>
+              </a:lnSpc>
+              <a:defRPr sz="1150">
+                <a:solidFill>
+                  <a:srgbClr val="1E293B"/>
+                </a:solidFill>
+                <a:latin typeface="Arial"/>
+              </a:defRPr>
+            </a:pPr>
+            <a:r>
+              <a:t>Pedregosa et al. (2011). 'Scikit-learn: Machine Learning in Python', Journal of Machine Learning Research.</a:t>
+            </a:r>
+            <a:br/>
+            <a:r>
+              <a:t>Breiman, L. (2001). 'Random Forests', Machine Learning, 45(1), 5-32.</a:t>
+            </a:r>
+          </a:p>
+        </p:txBody>
+      </p:sp>
+      <p:sp>
+        <p:nvSpPr>
+          <p:cNvPr id="12" name="Rounded Rectangle 11"/>
+          <p:cNvSpPr/>
+          <p:nvPr/>
+        </p:nvSpPr>
+        <p:spPr>
+          <a:xfrm>
+            <a:off x="594360" y="4251960"/>
+            <a:ext cx="5303520" cy="1920240"/>
+          </a:xfrm>
+          <a:prstGeom prst="roundRect">
+            <a:avLst/>
+          </a:prstGeom>
+          <a:solidFill>
+            <a:srgbClr val="F5F3FF"/>
+          </a:solidFill>
+          <a:ln w="12700">
+            <a:solidFill>
+              <a:srgbClr val="CBD5E1"/>
+            </a:solidFill>
+          </a:ln>
+        </p:spPr>
+        <p:style>
+          <a:lnRef idx="1">
+            <a:schemeClr val="accent1"/>
+          </a:lnRef>
+          <a:fillRef idx="3">
+            <a:schemeClr val="accent1"/>
+          </a:fillRef>
+          <a:effectRef idx="2">
+            <a:schemeClr val="accent1"/>
+          </a:effectRef>
+          <a:fontRef idx="minor">
+            <a:schemeClr val="lt1"/>
+          </a:fontRef>
+        </p:style>
+        <p:txBody>
+          <a:bodyPr rtlCol="0" anchor="ctr"/>
+          <a:lstStyle/>
+          <a:p>
+            <a:pPr algn="ctr"/>
+          </a:p>
+        </p:txBody>
+      </p:sp>
+      <p:sp>
+        <p:nvSpPr>
+          <p:cNvPr id="13" name="TextBox 12"/>
+          <p:cNvSpPr txBox="1"/>
+          <p:nvPr/>
+        </p:nvSpPr>
+        <p:spPr>
+          <a:xfrm>
+            <a:off x="777240" y="4434840"/>
+            <a:ext cx="4937760" cy="1554480"/>
+          </a:xfrm>
+          <a:prstGeom prst="rect">
+            <a:avLst/>
+          </a:prstGeom>
+          <a:noFill/>
+        </p:spPr>
+        <p:txBody>
+          <a:bodyPr wrap="square" anchor="ctr" lIns="0" tIns="0" rIns="0" bIns="0">
+            <a:spAutoFit/>
+          </a:bodyPr>
+          <a:lstStyle/>
+          <a:p>
+            <a:pPr algn="l">
+              <a:defRPr sz="1400" b="1">
+                <a:solidFill>
+                  <a:srgbClr val="11385B"/>
+                </a:solidFill>
+                <a:latin typeface="Arial"/>
+              </a:defRPr>
+            </a:pPr>
+            <a:r>
+              <a:t>Networking Standards &amp; Protocols</a:t>
+            </a:r>
+          </a:p>
+          <a:p>
+            <a:br/>
+            <a:pPr algn="l">
+              <a:lnSpc>
+                <a:spcPct val="125000"/>
+              </a:lnSpc>
+              <a:defRPr sz="1150">
+                <a:solidFill>
+                  <a:srgbClr val="1E293B"/>
+                </a:solidFill>
+                <a:latin typeface="Arial"/>
+              </a:defRPr>
+            </a:pPr>
+            <a:r>
+              <a:t>Fielding, R. et al. (2022). RFC 9110: HTTP Semantics, Internet Engineering Task Force (IETF).</a:t>
+            </a:r>
+            <a:br/>
+            <a:r>
+              <a:t>HAProxy Technologies (2024). 'Dynamic Weight and Queue Load Balancing Whitepaper'.</a:t>
+            </a:r>
+          </a:p>
+        </p:txBody>
+      </p:sp>
+      <p:sp>
+        <p:nvSpPr>
+          <p:cNvPr id="14" name="Rounded Rectangle 13"/>
+          <p:cNvSpPr/>
+          <p:nvPr/>
+        </p:nvSpPr>
+        <p:spPr>
+          <a:xfrm>
+            <a:off x="6217920" y="4251960"/>
+            <a:ext cx="5303520" cy="1920240"/>
+          </a:xfrm>
+          <a:prstGeom prst="roundRect">
+            <a:avLst/>
+          </a:prstGeom>
+          <a:solidFill>
+            <a:srgbClr val="F0FDF4"/>
+          </a:solidFill>
+          <a:ln w="12700">
+            <a:solidFill>
+              <a:srgbClr val="CBD5E1"/>
+            </a:solidFill>
+          </a:ln>
+        </p:spPr>
+        <p:style>
+          <a:lnRef idx="1">
+            <a:schemeClr val="accent1"/>
+          </a:lnRef>
+          <a:fillRef idx="3">
+            <a:schemeClr val="accent1"/>
+          </a:fillRef>
+          <a:effectRef idx="2">
+            <a:schemeClr val="accent1"/>
+          </a:effectRef>
+          <a:fontRef idx="minor">
+            <a:schemeClr val="lt1"/>
+          </a:fontRef>
+        </p:style>
+        <p:txBody>
+          <a:bodyPr rtlCol="0" anchor="ctr"/>
+          <a:lstStyle/>
+          <a:p>
+            <a:pPr algn="ctr"/>
+          </a:p>
+        </p:txBody>
+      </p:sp>
+      <p:sp>
+        <p:nvSpPr>
+          <p:cNvPr id="15" name="TextBox 14"/>
+          <p:cNvSpPr txBox="1"/>
+          <p:nvPr/>
+        </p:nvSpPr>
+        <p:spPr>
+          <a:xfrm>
+            <a:off x="6400800" y="4434840"/>
+            <a:ext cx="4937760" cy="1554480"/>
+          </a:xfrm>
+          <a:prstGeom prst="rect">
+            <a:avLst/>
+          </a:prstGeom>
+          <a:noFill/>
+        </p:spPr>
+        <p:txBody>
+          <a:bodyPr wrap="square" anchor="ctr" lIns="0" tIns="0" rIns="0" bIns="0">
+            <a:spAutoFit/>
+          </a:bodyPr>
+          <a:lstStyle/>
+          <a:p>
+            <a:pPr algn="l">
+              <a:defRPr sz="1400" b="1">
+                <a:solidFill>
+                  <a:srgbClr val="11385B"/>
+                </a:solidFill>
+                <a:latin typeface="Arial"/>
+              </a:defRPr>
+            </a:pPr>
+            <a:r>
+              <a:t>Project Repository &amp; Deliverables</a:t>
+            </a:r>
+          </a:p>
+          <a:p>
+            <a:br/>
+            <a:pPr algn="l">
+              <a:lnSpc>
+                <a:spcPct val="125000"/>
+              </a:lnSpc>
+              <a:defRPr sz="1150">
+                <a:solidFill>
+                  <a:srgbClr val="1E293B"/>
+                </a:solidFill>
+                <a:latin typeface="Arial"/>
+              </a:defRPr>
+            </a:pPr>
+            <a:r>
+              <a:t>Source code repository: github.com/Krishna-Modi12/ai-based-load-balancing</a:t>
+            </a:r>
+            <a:br/>
+            <a:r>
+              <a:t>Includes full test suite (36 passed), Docker Compose environment, and live React HUD.</a:t>
             </a:r>
           </a:p>
         </p:txBody>

</xml_diff>